<commit_message>
Updated data file paths
</commit_message>
<xml_diff>
--- a/Slides/GPGN268-Final-Presentation .pptx
+++ b/Slides/GPGN268-Final-Presentation .pptx
@@ -146,7 +146,7 @@
   <pc:docChgLst>
     <pc:chgData name="Kaitlyn Sanchez" userId="f90c757d64000272" providerId="LiveId" clId="{12FC0063-CB00-4DE9-8420-EDC7A485C72F}"/>
     <pc:docChg chg="undo custSel addSld delSld modSld sldOrd">
-      <pc:chgData name="Kaitlyn Sanchez" userId="f90c757d64000272" providerId="LiveId" clId="{12FC0063-CB00-4DE9-8420-EDC7A485C72F}" dt="2026-05-01T18:36:25.892" v="10948" actId="1076"/>
+      <pc:chgData name="Kaitlyn Sanchez" userId="f90c757d64000272" providerId="LiveId" clId="{12FC0063-CB00-4DE9-8420-EDC7A485C72F}" dt="2026-05-02T03:52:21.197" v="10952" actId="478"/>
       <pc:docMkLst>
         <pc:docMk/>
       </pc:docMkLst>
@@ -174,7 +174,7 @@
         </pc:spChg>
       </pc:sldChg>
       <pc:sldChg chg="addSp delSp modSp mod modNotesTx">
-        <pc:chgData name="Kaitlyn Sanchez" userId="f90c757d64000272" providerId="LiveId" clId="{12FC0063-CB00-4DE9-8420-EDC7A485C72F}" dt="2026-04-27T21:42:59.124" v="1565" actId="255"/>
+        <pc:chgData name="Kaitlyn Sanchez" userId="f90c757d64000272" providerId="LiveId" clId="{12FC0063-CB00-4DE9-8420-EDC7A485C72F}" dt="2026-05-02T03:52:21.197" v="10952" actId="478"/>
         <pc:sldMkLst>
           <pc:docMk/>
           <pc:sldMk cId="3497227369" sldId="300"/>
@@ -187,8 +187,16 @@
             <ac:spMk id="2" creationId="{CE1B8232-8B55-A36B-A924-C8B86E1BA15D}"/>
           </ac:spMkLst>
         </pc:spChg>
+        <pc:spChg chg="add del">
+          <ac:chgData name="Kaitlyn Sanchez" userId="f90c757d64000272" providerId="LiveId" clId="{12FC0063-CB00-4DE9-8420-EDC7A485C72F}" dt="2026-05-02T03:52:21.197" v="10952" actId="478"/>
+          <ac:spMkLst>
+            <pc:docMk/>
+            <pc:sldMk cId="3497227369" sldId="300"/>
+            <ac:spMk id="4" creationId="{3E4B64C1-E205-5410-61D8-6E41C8014BB4}"/>
+          </ac:spMkLst>
+        </pc:spChg>
         <pc:spChg chg="mod">
-          <ac:chgData name="Kaitlyn Sanchez" userId="f90c757d64000272" providerId="LiveId" clId="{12FC0063-CB00-4DE9-8420-EDC7A485C72F}" dt="2026-04-27T21:42:59.124" v="1565" actId="255"/>
+          <ac:chgData name="Kaitlyn Sanchez" userId="f90c757d64000272" providerId="LiveId" clId="{12FC0063-CB00-4DE9-8420-EDC7A485C72F}" dt="2026-05-02T03:52:17.481" v="10951" actId="6549"/>
           <ac:spMkLst>
             <pc:docMk/>
             <pc:sldMk cId="3497227369" sldId="300"/>
@@ -9820,7 +9828,7 @@
               <a:buChar char="•"/>
             </a:pPr>
             <a:r>
-              <a:rPr lang="en-US" sz="2400" b="1" dirty="0">
+              <a:rPr lang="en-US" sz="2400" b="1">
                 <a:solidFill>
                   <a:schemeClr val="bg1"/>
                 </a:solidFill>

</xml_diff>